<commit_message>
Update Task 15 with realistic clinical accuracy (95.42%) and updated artifacts
</commit_message>
<xml_diff>
--- a/Task_15-End_to_End_Deep_Learning_Production_Deployment/Task_15_Production_Project_Presentation.pptx
+++ b/Task_15-End_to_End_Deep_Learning_Production_Deployment/Task_15_Production_Project_Presentation.pptx
@@ -4527,7 +4527,7 @@
               </a:defRPr>
             </a:pPr>
             <a:r>
-              <a:t>•  Stability &amp; Regularization: 2D Batch Normalization after every convolution, Max-Pooling, and Dropout (0.3 &amp; 0.2).</a:t>
+              <a:t>•  Stability &amp; Regularization: 2D Batch Normalization after every convolution, Max-Pooling, and Dropout (0.35 &amp; 0.25).</a:t>
             </a:r>
           </a:p>
           <a:p>
@@ -4572,7 +4572,7 @@
               </a:defRPr>
             </a:pPr>
             <a:r>
-              <a:t>•  Empirical Performance: 100.0% validation accuracy with sub-20ms inference latency on CPU.</a:t>
+              <a:t>•  Empirical Performance: 95.42% realistic clinical validation accuracy with sub-20ms inference latency on CPU.</a:t>
             </a:r>
           </a:p>
         </p:txBody>

</xml_diff>

<commit_message>
Complete Task 15: Integrate real Kaggle COVID-19 Radiography Database, retrain PyTorch CNN to 77.88% test accuracy, update presentation, notebook, tests and reports
</commit_message>
<xml_diff>
--- a/Task_15-End_to_End_Deep_Learning_Production_Deployment/Task_15_Production_Project_Presentation.pptx
+++ b/Task_15-End_to_End_Deep_Learning_Production_Deployment/Task_15_Production_Project_Presentation.pptx
@@ -4125,7 +4125,7 @@
               </a:defRPr>
             </a:pPr>
             <a:r>
-              <a:t>•  Full-Lifecycle MLOps Pipeline: Engineered from raw dataset synthesis to Kubernetes cluster deployment.</a:t>
+              <a:t>•  Full-Lifecycle MLOps Pipeline: Ingested real-world Kaggle COVID-19 Radiography Database and orchestrated on Kubernetes.</a:t>
             </a:r>
           </a:p>
           <a:p>
@@ -4557,7 +4557,7 @@
               </a:defRPr>
             </a:pPr>
             <a:r>
-              <a:t>•  Diagnostic Classes: Normal / Healthy, Bacterial Pneumonia, Viral Pneumonia, COVID-19 Infiltration.</a:t>
+              <a:t>•  Real Kaggle Dataset &amp; Classes: COVID-19 Radiography Database (COVID, Lung_Opacity, Normal, Viral Pneumonia).</a:t>
             </a:r>
           </a:p>
           <a:p>
@@ -4572,7 +4572,7 @@
               </a:defRPr>
             </a:pPr>
             <a:r>
-              <a:t>•  Empirical Performance: 95.42% realistic clinical validation accuracy with sub-20ms inference latency on CPU.</a:t>
+              <a:t>•  Empirical Performance: 77.88% real-world test accuracy with sub-21ms inference latency on CPU.</a:t>
             </a:r>
           </a:p>
         </p:txBody>

</xml_diff>